<commit_message>
chore: refresh defense deck and repository QR
</commit_message>
<xml_diff>
--- a/papers/dist/JointAdaSpec_defense.pptx
+++ b/papers/dist/JointAdaSpec_defense.pptx
@@ -585,7 +585,7 @@
           <a:lstStyle/>
           <a:p>
             <a:r>
-              <a:t>Нужна ли адаптивность, если порог можно подобрать? Совместная политика доминирует любой фиксированный порог сразу по точности и по скорости.</a:t>
+              <a:t>Нужна ли адаптивность, если порог можно подобрать? Pre-repair ablation показывает мотивацию, но финальный block-v1 результат требует повторного прогона.</a:t>
             </a:r>
           </a:p>
         </p:txBody>
@@ -795,7 +795,7 @@
           <a:lstStyle/>
           <a:p>
             <a:r>
-              <a:t>На защиту выносятся четыре положения: формализуемость совместного управления как конечного MDP; доказанные теоретические свойства; значимое превосходство над неадаптивными базисами; границы применимости.</a:t>
+              <a:t>На защиту выносятся четыре положения: формализуемость совместного управления как конечного MDP; доказанные теоретические свойства; исправленная реализация и защита артефактов; границы применимости.</a:t>
             </a:r>
           </a:p>
         </p:txBody>
@@ -865,7 +865,7 @@
           <a:lstStyle/>
           <a:p>
             <a:r>
-              <a:t>Весь код, тесты, манифесты и полный текст работы открыты — QR ведёт в репозиторий. Спасибо за внимание, готов ответить на вопросы.</a:t>
+              <a:t>Весь код, тесты, манифесты и полный текст работы открыты — QR ведёт на immutable snapshot v1-defense. Спасибо за внимание, готов ответить на вопросы.</a:t>
             </a:r>
           </a:p>
         </p:txBody>
@@ -1425,7 +1425,7 @@
           <a:lstStyle/>
           <a:p>
             <a:r>
-              <a:t>Адаптивное управление повышает точность на +4 пункта при значимости p=0,02 и восстанавливает пропускную способность до 2,2× от ванильного спекулятивного декодирования.</a:t>
+              <a:t>Это исторический крупный прогон и мотивационное свидетельство. После аудита он помечен как legacy evidence: финальный block-v1 claim требует rerun с новой 9-action policy.</a:t>
             </a:r>
           </a:p>
         </p:txBody>
@@ -4893,7 +4893,7 @@
                 </a:solidFill>
                 <a:latin typeface="Calibri"/>
               </a:rPr>
-              <a:t>СРАВНЕНИЕ С ФИКСИРОВАННЫМ ПОРОГОМ · N = 300</a:t>
+              <a:t>PRE-REPAIR ABLATION · N = 300</a:t>
             </a:r>
           </a:p>
         </p:txBody>
@@ -4927,7 +4927,7 @@
                 </a:solidFill>
                 <a:latin typeface="Calibri"/>
               </a:rPr>
-              <a:t>Адаптивность нетривиальна: теорема E</a:t>
+              <a:t>Адаптивность нетривиальна: эксперимент E</a:t>
             </a:r>
           </a:p>
         </p:txBody>
@@ -5112,6 +5112,41 @@
                 <a:latin typeface="Calibri"/>
               </a:rPr>
               <a:t> (11,12 против ≈ 3,0 ток/с).</a:t>
+            </a:r>
+          </a:p>
+        </p:txBody>
+      </p:sp>
+      <p:sp>
+        <p:nvSpPr>
+          <p:cNvPr id="11" name="TextBox 10"/>
+          <p:cNvSpPr txBox="1"/>
+          <p:nvPr/>
+        </p:nvSpPr>
+        <p:spPr>
+          <a:xfrm>
+            <a:off x="2194560" y="6428232"/>
+            <a:ext cx="7772400" cy="320040"/>
+          </a:xfrm>
+          <a:prstGeom prst="rect">
+            <a:avLst/>
+          </a:prstGeom>
+          <a:noFill/>
+        </p:spPr>
+        <p:txBody>
+          <a:bodyPr wrap="square" anchor="t" lIns="0" rIns="0" tIns="0" bIns="0">
+            <a:spAutoFit/>
+          </a:bodyPr>
+          <a:lstStyle/>
+          <a:p>
+            <a:pPr algn="ctr"/>
+            <a:r>
+              <a:rPr sz="1000" b="1" i="0">
+                <a:solidFill>
+                  <a:srgbClr val="B5852A"/>
+                </a:solidFill>
+                <a:latin typeface="Calibri"/>
+              </a:rPr>
+              <a:t>Мотивационная ablation evidence; финальный block-v1 результат требует rerun.</a:t>
             </a:r>
           </a:p>
         </p:txBody>
@@ -6009,7 +6044,7 @@
                 </a:solidFill>
                 <a:latin typeface="Calibri"/>
               </a:rPr>
-              <a:t>Единый MDP-фреймворк совместного управления (длина, порог) — первый в литературе.</a:t>
+              <a:t>Единый MDP-фреймворк совместного управления (длина, порог) — одна из первых табличных постановок в литературе.</a:t>
             </a:r>
           </a:p>
         </p:txBody>
@@ -6628,7 +6663,7 @@
                 </a:solidFill>
                 <a:latin typeface="Calibri"/>
               </a:rPr>
-              <a:t>Доказаны выборочная сложность (A), Беллман-инвариантность штрафа (B), оценка и точный разрыв совместной и каскадной политик (C, D), слабое доминирование (2.3) и Парето-скаляризация (2.4).</a:t>
+              <a:t>Доказаны выборочная сложность (A), исправленная reward-shaping формулировка (B), оценка и точный разрыв совместной и каскадной политик (C, D), слабое доминирование (2.3) и Парето-скаляризация (2.4).</a:t>
             </a:r>
           </a:p>
           <a:p>
@@ -6653,7 +6688,7 @@
                 </a:solidFill>
                 <a:latin typeface="Calibri"/>
               </a:rPr>
-              <a:t>Адаптивное управление значимо превосходит все неадаптивные базисы: +4,07 п.п. EM на 14B/0.5B (p = 0,0205) и +4…+8 п.п. над фиксированным порогом при ≈ 3,7× скорости.</a:t>
+              <a:t>Реализован block-v1 pipeline с семантической валидацией: legacy 16-action policies не переиспользуются как новые результаты.</a:t>
             </a:r>
           </a:p>
           <a:p>
@@ -6678,7 +6713,7 @@
                 </a:solidFill>
                 <a:latin typeface="Calibri"/>
               </a:rPr>
-              <a:t>Установлены границы применимости: метод сводится к каскадной политике (теорема D) и не даёт выигрыша при низком отношении мощностей моделей.</a:t>
+              <a:t>Legacy-прогоны показывают потенциал; финальный block-v1 claim требует rerun. Установлены границы применимости: joint ≈ cascade и нуль на низком отношении мощностей.</a:t>
             </a:r>
           </a:p>
         </p:txBody>
@@ -6959,13 +6994,13 @@
               </a:spcBef>
             </a:pPr>
             <a:r>
-              <a:rPr sz="1600" b="1" i="0">
+              <a:rPr sz="1300" b="1" i="0">
                 <a:solidFill>
                   <a:srgbClr val="2BB3A3"/>
                 </a:solidFill>
                 <a:latin typeface="DejaVu Sans Mono"/>
               </a:rPr>
-              <a:t>github.com/levvius/adaptive-speculative-decoding</a:t>
+              <a:t>github.com/levvius/adaptive-speculative-decoding/tree/v1-defense</a:t>
             </a:r>
           </a:p>
         </p:txBody>
@@ -9712,7 +9747,7 @@
                 </a:solidFill>
                 <a:latin typeface="Calibri"/>
               </a:rPr>
-              <a:t>Действие a = (длина ∈ {stop, continue}, порог T из 8 уровней); |S| = 3600, |A| = 16.</a:t>
+              <a:t>Действие a ∈ {continue} ∪ {verify@T}; |S| = 3600, |A| = 9.</a:t>
             </a:r>
           </a:p>
           <a:p>
@@ -10018,7 +10053,7 @@
                 <a:latin typeface="Calibri"/>
               </a:rPr>
               <a:t>Действие
-(длина, порог T)</a:t>
+continue/verify@T</a:t>
             </a:r>
           </a:p>
         </p:txBody>
@@ -10433,7 +10468,7 @@
                 </a:solidFill>
                 <a:latin typeface="Calibri"/>
               </a:rPr>
-              <a:t>Беллман-инвариантность аддитивного штрафа качества</a:t>
+              <a:t>исправленная reward-shaping формулировка</a:t>
             </a:r>
           </a:p>
         </p:txBody>
@@ -11614,7 +11649,7 @@
                 </a:solidFill>
                 <a:latin typeface="Calibri"/>
               </a:rPr>
-              <a:t>GSM8K · N = 1500 · MCNEMAR</a:t>
+              <a:t>PRE-REPAIR ARTIFACT · GSM8K · N = 1500</a:t>
             </a:r>
           </a:p>
         </p:txBody>
@@ -11648,7 +11683,7 @@
                 </a:solidFill>
                 <a:latin typeface="Calibri"/>
               </a:rPr>
-              <a:t>Результаты: пара 14B / 0.5B</a:t>
+              <a:t>Legacy evidence: пара 14B / 0.5B</a:t>
             </a:r>
           </a:p>
         </p:txBody>
@@ -12380,7 +12415,7 @@
           <a:p>
             <a:pPr algn="ctr"/>
             <a:r>
-              <a:rPr sz="5400" b="1" i="0">
+              <a:rPr sz="5000" b="1" i="0">
                 <a:solidFill>
                   <a:srgbClr val="1E9E5A"/>
                 </a:solidFill>
@@ -12392,13 +12427,13 @@
           <a:p>
             <a:pPr algn="ctr"/>
             <a:r>
-              <a:rPr sz="1600" b="0" i="0">
+              <a:rPr sz="1500" b="0" i="0">
                 <a:solidFill>
                   <a:srgbClr val="1F2430"/>
                 </a:solidFill>
                 <a:latin typeface="Calibri"/>
               </a:rPr>
-              <a:t>EM к прямой генерации (p = 0,0205)</a:t>
+              <a:t>legacy EM к target (p = 0,0205)</a:t>
             </a:r>
           </a:p>
           <a:p>
@@ -12420,6 +12455,18 @@
                 <a:latin typeface="Calibri"/>
               </a:rPr>
               <a:t>пропускной способности (к ванильному SD)</a:t>
+            </a:r>
+          </a:p>
+          <a:p>
+            <a:pPr algn="ctr"/>
+            <a:r>
+              <a:rPr sz="1200" b="1" i="0">
+                <a:solidFill>
+                  <a:srgbClr val="B5852A"/>
+                </a:solidFill>
+                <a:latin typeface="Calibri"/>
+              </a:rPr>
+              <a:t>не финальный block-v1 claim без rerun</a:t>
             </a:r>
           </a:p>
         </p:txBody>

</xml_diff>

<commit_message>
chore: rebuild defense deck after final audit
</commit_message>
<xml_diff>
--- a/papers/dist/JointAdaSpec_defense.pptx
+++ b/papers/dist/JointAdaSpec_defense.pptx
@@ -1355,7 +1355,7 @@
           <a:lstStyle/>
           <a:p>
             <a:r>
-              <a:t>Метод реализован как воспроизводимый конвейер: каждый прогон детерминирован и сопровождается манифестом, ядро покрыто 72 тестами.</a:t>
+              <a:t>Метод реализован как воспроизводимый конвейер: каждый прогон детерминирован и сопровождается манифестом; на defense snapshot полный pytest-набор прошёл как 94 теста.</a:t>
             </a:r>
           </a:p>
         </p:txBody>
@@ -6973,7 +6973,7 @@
                 </a:solidFill>
                 <a:latin typeface="Calibri"/>
               </a:rPr>
-              <a:t>Репозиторий: код, 72 теста, манифесты воспроизводимости,</a:t>
+              <a:t>Репозиторий: код, 94 pytest-теста, манифесты воспроизводимости,</a:t>
             </a:r>
           </a:p>
           <a:p>
@@ -11415,7 +11415,7 @@
                 </a:solidFill>
                 <a:latin typeface="Calibri"/>
               </a:rPr>
-              <a:t>Стек: Python 3.12, PyTorch, scipy.sparse, Hydra; ядро покрыто 72 модульными тестами.</a:t>
+              <a:t>Стек: Python 3.12, PyTorch, scipy.sparse, Hydra; полный pytest-набор: 94 теста на v1-defense.</a:t>
             </a:r>
           </a:p>
           <a:p>

</xml_diff>

<commit_message>
chore: rebuild defense deck for thesis snapshot framing
</commit_message>
<xml_diff>
--- a/papers/dist/JointAdaSpec_defense.pptx
+++ b/papers/dist/JointAdaSpec_defense.pptx
@@ -585,7 +585,7 @@
           <a:lstStyle/>
           <a:p>
             <a:r>
-              <a:t>Нужна ли адаптивность, если порог можно подобрать? Pre-repair ablation показывает мотивацию, но финальный block-v1 результат требует повторного прогона.</a:t>
+              <a:t>Нужна ли адаптивность, если порог можно подобрать? Thesis-snapshot ablation показывает мотивацию, а новые post-defense claims выносятся в main.</a:t>
             </a:r>
           </a:p>
         </p:txBody>
@@ -865,7 +865,7 @@
           <a:lstStyle/>
           <a:p>
             <a:r>
-              <a:t>Весь код, тесты, манифесты и полный текст работы открыты — QR ведёт на immutable snapshot v1-defense. Спасибо за внимание, готов ответить на вопросы.</a:t>
+              <a:t>Код, тесты, манифесты, deck, audit/Q&amp;A и текст работы открыты — QR ведёт на immutable snapshot v1-defense. Спасибо за внимание, готов ответить на вопросы.</a:t>
             </a:r>
           </a:p>
         </p:txBody>
@@ -1425,7 +1425,7 @@
           <a:lstStyle/>
           <a:p>
             <a:r>
-              <a:t>Это исторический крупный прогон и мотивационное свидетельство. После аудита он помечен как legacy evidence: финальный block-v1 claim требует rerun с новой 9-action policy.</a:t>
+              <a:t>Это зафиксированный artifact-backed результат snapshot ВКР. Новые post-defense block-v1 claims делаются отдельно в main, чтобы не смешивать поколения артефактов.</a:t>
             </a:r>
           </a:p>
         </p:txBody>
@@ -4677,7 +4677,7 @@
                 </a:solidFill>
                 <a:latin typeface="Calibri"/>
               </a:rPr>
-              <a:t>Научный руководитель: ______________________</a:t>
+              <a:t>Научный руководитель: Калайдина Г.В.</a:t>
             </a:r>
           </a:p>
           <a:p>
@@ -4893,7 +4893,7 @@
                 </a:solidFill>
                 <a:latin typeface="Calibri"/>
               </a:rPr>
-              <a:t>PRE-REPAIR ABLATION · N = 300</a:t>
+              <a:t>THESIS-SNAPSHOT ABLATION · N = 300</a:t>
             </a:r>
           </a:p>
         </p:txBody>
@@ -5146,7 +5146,7 @@
                 </a:solidFill>
                 <a:latin typeface="Calibri"/>
               </a:rPr>
-              <a:t>Мотивационная ablation evidence; финальный block-v1 результат требует rerun.</a:t>
+              <a:t>Ablation evidence для snapshot ВКР; новые block-v1 claims требуют rerun в main.</a:t>
             </a:r>
           </a:p>
         </p:txBody>
@@ -6688,7 +6688,7 @@
                 </a:solidFill>
                 <a:latin typeface="Calibri"/>
               </a:rPr>
-              <a:t>Реализован block-v1 pipeline с семантической валидацией: legacy 16-action policies не переиспользуются как новые результаты.</a:t>
+              <a:t>Реализован block-v1 pipeline с семантической валидацией: разные поколения policies не смешиваются неявно.</a:t>
             </a:r>
           </a:p>
           <a:p>
@@ -6713,7 +6713,7 @@
                 </a:solidFill>
                 <a:latin typeface="Calibri"/>
               </a:rPr>
-              <a:t>Legacy-прогоны показывают потенциал; финальный block-v1 claim требует rerun. Установлены границы применимости: joint ≈ cascade и нуль на низком отношении мощностей.</a:t>
+              <a:t>Зафиксированные прогоны показывают потенциал; fresh block-v1 claims выносятся в post-defense main. Установлены границы применимости: joint ≈ cascade и нуль на низком отношении мощностей.</a:t>
             </a:r>
           </a:p>
         </p:txBody>
@@ -6984,7 +6984,7 @@
                 </a:solidFill>
                 <a:latin typeface="Calibri"/>
               </a:rPr>
-              <a:t>полный текст ВКР и план презентации.</a:t>
+              <a:t>текст ВКР, deck, audit/Q&amp;A и артефакты.</a:t>
             </a:r>
           </a:p>
           <a:p>
@@ -11649,7 +11649,7 @@
                 </a:solidFill>
                 <a:latin typeface="Calibri"/>
               </a:rPr>
-              <a:t>PRE-REPAIR ARTIFACT · GSM8K · N = 1500</a:t>
+              <a:t>ARTIFACT-BACKED RESULT · GSM8K · N = 1500</a:t>
             </a:r>
           </a:p>
         </p:txBody>
@@ -11683,7 +11683,7 @@
                 </a:solidFill>
                 <a:latin typeface="Calibri"/>
               </a:rPr>
-              <a:t>Legacy evidence: пара 14B / 0.5B</a:t>
+              <a:t>Thesis snapshot: пара 14B / 0.5B</a:t>
             </a:r>
           </a:p>
         </p:txBody>
@@ -12433,7 +12433,7 @@
                 </a:solidFill>
                 <a:latin typeface="Calibri"/>
               </a:rPr>
-              <a:t>legacy EM к target (p = 0,0205)</a:t>
+              <a:t>snapshot EM к target (p = 0,0205)</a:t>
             </a:r>
           </a:p>
           <a:p>
@@ -12466,7 +12466,7 @@
                 </a:solidFill>
                 <a:latin typeface="Calibri"/>
               </a:rPr>
-              <a:t>не финальный block-v1 claim без rerun</a:t>
+              <a:t>artifact-backed thesis result; fresh claims — в main</a:t>
             </a:r>
           </a:p>
         </p:txBody>

</xml_diff>